<commit_message>
Add assets: updated deck PDF, architecture diagram, demo video, and HyperFrames project
- deck/FirstPass_PortSwigger.pdf: updated deck with clickable GitHub link on cover
- assets/AI_Contract_Triage_System.png: architecture diagram
- videos/firstpass-demo.mp4: rendered 56s product demo video (HyperFrames)
- videos/Video_Project.mp4: high-quality video project (LFS)
- videos/firstpass-promos/: full HyperFrames project (9 frames, broadside preset)
- Updated README with links to all new assets
</commit_message>
<xml_diff>
--- a/deck/FirstPass_PortSwigger.pptx
+++ b/deck/FirstPass_PortSwigger.pptx
@@ -3487,6 +3487,46 @@
         </p:nvSpPr>
         <p:spPr>
           <a:xfrm>
+            <a:off x="777240" y="5943600"/>
+            <a:ext cx="7315200" cy="365760"/>
+          </a:xfrm>
+          <a:prstGeom prst="rect">
+            <a:avLst/>
+          </a:prstGeom>
+          <a:noFill/>
+        </p:spPr>
+        <p:txBody>
+          <a:bodyPr wrap="square" anchor="t" lIns="0" rIns="0" tIns="0" bIns="0">
+            <a:spAutoFit/>
+          </a:bodyPr>
+          <a:lstStyle/>
+          <a:p>
+            <a:pPr algn="l">
+              <a:lnSpc>
+                <a:spcPct val="104000"/>
+              </a:lnSpc>
+            </a:pPr>
+            <a:r>
+              <a:rPr sz="1250" b="1" i="0">
+                <a:solidFill>
+                  <a:srgbClr val="E14E12"/>
+                </a:solidFill>
+                <a:latin typeface="Arial"/>
+                <a:hlinkClick r:id="rId2"/>
+              </a:rPr>
+              <a:t>github.com/Abdelrhman-Rayis/FirstPass</a:t>
+            </a:r>
+          </a:p>
+        </p:txBody>
+      </p:sp>
+      <p:sp>
+        <p:nvSpPr>
+          <p:cNvPr id="12" name="TextBox 11"/>
+          <p:cNvSpPr txBox="1"/>
+          <p:nvPr/>
+        </p:nvSpPr>
+        <p:spPr>
+          <a:xfrm>
             <a:off x="8945575" y="1828800"/>
             <a:ext cx="2560320" cy="365760"/>
           </a:xfrm>
@@ -3520,7 +3560,7 @@
       </p:sp>
       <p:sp>
         <p:nvSpPr>
-          <p:cNvPr id="12" name="Rounded Rectangle 11"/>
+          <p:cNvPr id="13" name="Rounded Rectangle 12"/>
           <p:cNvSpPr/>
           <p:nvPr/>
         </p:nvSpPr>
@@ -3575,7 +3615,7 @@
       </p:sp>
       <p:sp>
         <p:nvSpPr>
-          <p:cNvPr id="13" name="Rounded Rectangle 12"/>
+          <p:cNvPr id="14" name="Rounded Rectangle 13"/>
           <p:cNvSpPr/>
           <p:nvPr/>
         </p:nvSpPr>
@@ -3630,7 +3670,7 @@
       </p:sp>
       <p:sp>
         <p:nvSpPr>
-          <p:cNvPr id="14" name="Rounded Rectangle 13"/>
+          <p:cNvPr id="15" name="Rounded Rectangle 14"/>
           <p:cNvSpPr/>
           <p:nvPr/>
         </p:nvSpPr>
@@ -3685,7 +3725,7 @@
       </p:sp>
       <p:sp>
         <p:nvSpPr>
-          <p:cNvPr id="15" name="TextBox 14"/>
+          <p:cNvPr id="16" name="TextBox 15"/>
           <p:cNvSpPr txBox="1"/>
           <p:nvPr/>
         </p:nvSpPr>

</xml_diff>